<commit_message>
Fix presentation package paths
</commit_message>
<xml_diff>
--- a/DIR_DIVING_Project_Presentation.pptx
+++ b/DIR_DIVING_Project_Presentation.pptx
@@ -1,27 +1,5 @@
 
-<file path=docProps\app.xml><?xml version="1.0" encoding="utf-8"?>
-<Properties xmlns="http://schemas.openxmlformats.org/officeDocument/2006/extended-properties" xmlns:vt="http://schemas.openxmlformats.org/officeDocument/2006/docPropsVTypes">
-  <Application>DIR DIVING</Application>
-  <PresentationFormat>On-screen Show (16:9)</PresentationFormat>
-  <Slides>9</Slides>
-</Properties>
-</file>
-
-<file path=docProps\core.xml><?xml version="1.0" encoding="utf-8"?>
-<cp:coreProperties xmlns:cp="http://schemas.openxmlformats.org/package/2006/metadata/core-properties" xmlns:dc="http://purl.org/dc/elements/1.1/" xmlns:dcterms="http://purl.org/dc/terms/" xmlns:dcmitype="http://purl.org/dc/dcmitype/" xmlns:xsi="http://www.w3.org/2001/XMLSchema-instance">
-  <dc:title>DIR DIVING Project Presentation</dc:title>
-  <dc:creator>DIR DIVING</dc:creator>
-  <cp:lastModifiedBy>DIR DIVING</cp:lastModifiedBy>
-  <dcterms:created xsi:type="dcterms:W3CDTF">2026-05-08T14:56:35Z</dcterms:created>
-  <dcterms:modified xsi:type="dcterms:W3CDTF">2026-05-08T14:56:35Z</dcterms:modified>
-</cp:coreProperties>
-</file>
-
-<file path=ppt\presProps.xml><?xml version="1.0" encoding="utf-8"?>
-<p:presentationPr xmlns:p="http://schemas.openxmlformats.org/presentationml/2006/main"/>
-</file>
-
-<file path=ppt\presentation.xml><?xml version="1.0" encoding="utf-8"?>
+<file path=ppt/presentation.xml><?xml version="1.0" encoding="utf-8"?>
 <p:presentation xmlns:a="http://schemas.openxmlformats.org/drawingml/2006/main" xmlns:r="http://schemas.openxmlformats.org/officeDocument/2006/relationships" xmlns:p="http://schemas.openxmlformats.org/presentationml/2006/main">
   <p:sldMasterIdLst>
     <p:sldMasterId id="2147483648" r:id="rId10"/>
@@ -43,7 +21,7 @@
 </p:presentation>
 </file>
 
-<file path=ppt\slideLayouts\slideLayout1.xml><?xml version="1.0" encoding="utf-8"?>
+<file path=ppt/slideLayouts/slideLayout1.xml><?xml version="1.0" encoding="utf-8"?>
 <p:sldLayout xmlns:a="http://schemas.openxmlformats.org/drawingml/2006/main" xmlns:r="http://schemas.openxmlformats.org/officeDocument/2006/relationships" xmlns:p="http://schemas.openxmlformats.org/presentationml/2006/main" type="blank" preserve="1">
   <p:cSld name="Blank">
     <p:spTree>
@@ -68,7 +46,7 @@
 </p:sldLayout>
 </file>
 
-<file path=ppt\slideMasters\slideMaster1.xml><?xml version="1.0" encoding="utf-8"?>
+<file path=ppt/slideMasters/slideMaster1.xml><?xml version="1.0" encoding="utf-8"?>
 <p:sldMaster xmlns:a="http://schemas.openxmlformats.org/drawingml/2006/main" xmlns:r="http://schemas.openxmlformats.org/officeDocument/2006/relationships" xmlns:p="http://schemas.openxmlformats.org/presentationml/2006/main">
   <p:cSld>
     <p:spTree>
@@ -94,7 +72,7 @@
 </p:sldMaster>
 </file>
 
-<file path=ppt\slides\slide1.xml><?xml version="1.0" encoding="utf-8"?>
+<file path=ppt/slides/slide1.xml><?xml version="1.0" encoding="utf-8"?>
 <p:sld xmlns:a="http://schemas.openxmlformats.org/drawingml/2006/main" xmlns:r="http://schemas.openxmlformats.org/officeDocument/2006/relationships" xmlns:p="http://schemas.openxmlformats.org/presentationml/2006/main">
   <p:cSld>
     <p:bg>
@@ -421,7 +399,7 @@
 </p:sld>
 </file>
 
-<file path=ppt\slides\slide2.xml><?xml version="1.0" encoding="utf-8"?>
+<file path=ppt/slides/slide2.xml><?xml version="1.0" encoding="utf-8"?>
 <p:sld xmlns:a="http://schemas.openxmlformats.org/drawingml/2006/main" xmlns:r="http://schemas.openxmlformats.org/officeDocument/2006/relationships" xmlns:p="http://schemas.openxmlformats.org/presentationml/2006/main">
   <p:cSld>
     <p:bg>
@@ -748,7 +726,7 @@
 </p:sld>
 </file>
 
-<file path=ppt\slides\slide3.xml><?xml version="1.0" encoding="utf-8"?>
+<file path=ppt/slides/slide3.xml><?xml version="1.0" encoding="utf-8"?>
 <p:sld xmlns:a="http://schemas.openxmlformats.org/drawingml/2006/main" xmlns:r="http://schemas.openxmlformats.org/officeDocument/2006/relationships" xmlns:p="http://schemas.openxmlformats.org/presentationml/2006/main">
   <p:cSld>
     <p:bg>
@@ -1075,7 +1053,7 @@
 </p:sld>
 </file>
 
-<file path=ppt\slides\slide4.xml><?xml version="1.0" encoding="utf-8"?>
+<file path=ppt/slides/slide4.xml><?xml version="1.0" encoding="utf-8"?>
 <p:sld xmlns:a="http://schemas.openxmlformats.org/drawingml/2006/main" xmlns:r="http://schemas.openxmlformats.org/officeDocument/2006/relationships" xmlns:p="http://schemas.openxmlformats.org/presentationml/2006/main">
   <p:cSld>
     <p:bg>
@@ -1402,7 +1380,7 @@
 </p:sld>
 </file>
 
-<file path=ppt\slides\slide5.xml><?xml version="1.0" encoding="utf-8"?>
+<file path=ppt/slides/slide5.xml><?xml version="1.0" encoding="utf-8"?>
 <p:sld xmlns:a="http://schemas.openxmlformats.org/drawingml/2006/main" xmlns:r="http://schemas.openxmlformats.org/officeDocument/2006/relationships" xmlns:p="http://schemas.openxmlformats.org/presentationml/2006/main">
   <p:cSld>
     <p:bg>
@@ -1729,7 +1707,7 @@
 </p:sld>
 </file>
 
-<file path=ppt\slides\slide6.xml><?xml version="1.0" encoding="utf-8"?>
+<file path=ppt/slides/slide6.xml><?xml version="1.0" encoding="utf-8"?>
 <p:sld xmlns:a="http://schemas.openxmlformats.org/drawingml/2006/main" xmlns:r="http://schemas.openxmlformats.org/officeDocument/2006/relationships" xmlns:p="http://schemas.openxmlformats.org/presentationml/2006/main">
   <p:cSld>
     <p:bg>
@@ -2056,7 +2034,7 @@
 </p:sld>
 </file>
 
-<file path=ppt\slides\slide7.xml><?xml version="1.0" encoding="utf-8"?>
+<file path=ppt/slides/slide7.xml><?xml version="1.0" encoding="utf-8"?>
 <p:sld xmlns:a="http://schemas.openxmlformats.org/drawingml/2006/main" xmlns:r="http://schemas.openxmlformats.org/officeDocument/2006/relationships" xmlns:p="http://schemas.openxmlformats.org/presentationml/2006/main">
   <p:cSld>
     <p:bg>
@@ -2383,7 +2361,7 @@
 </p:sld>
 </file>
 
-<file path=ppt\slides\slide8.xml><?xml version="1.0" encoding="utf-8"?>
+<file path=ppt/slides/slide8.xml><?xml version="1.0" encoding="utf-8"?>
 <p:sld xmlns:a="http://schemas.openxmlformats.org/drawingml/2006/main" xmlns:r="http://schemas.openxmlformats.org/officeDocument/2006/relationships" xmlns:p="http://schemas.openxmlformats.org/presentationml/2006/main">
   <p:cSld>
     <p:bg>
@@ -2710,7 +2688,7 @@
 </p:sld>
 </file>
 
-<file path=ppt\slides\slide9.xml><?xml version="1.0" encoding="utf-8"?>
+<file path=ppt/slides/slide9.xml><?xml version="1.0" encoding="utf-8"?>
 <p:sld xmlns:a="http://schemas.openxmlformats.org/drawingml/2006/main" xmlns:r="http://schemas.openxmlformats.org/officeDocument/2006/relationships" xmlns:p="http://schemas.openxmlformats.org/presentationml/2006/main">
   <p:cSld>
     <p:bg>
@@ -3037,7 +3015,7 @@
 </p:sld>
 </file>
 
-<file path=ppt\theme\theme1.xml><?xml version="1.0" encoding="utf-8"?>
+<file path=ppt/theme/theme1.xml><?xml version="1.0" encoding="utf-8"?>
 <a:theme xmlns:a="http://schemas.openxmlformats.org/drawingml/2006/main" name="DIR DIVING">
   <a:themeElements>
     <a:clrScheme name="DIR DIVING">
@@ -3112,8 +3090,4 @@
     </a:fmtScheme>
   </a:themeElements>
 </a:theme>
-</file>
-
-<file path=ppt\viewProps.xml><?xml version="1.0" encoding="utf-8"?>
-<p:viewPr xmlns:p="http://schemas.openxmlformats.org/presentationml/2006/main"/>
 </file>
</xml_diff>

<commit_message>
Use supplied watch reference look
</commit_message>
<xml_diff>
--- a/DIR_DIVING_Project_Presentation.pptx
+++ b/DIR_DIVING_Project_Presentation.pptx
@@ -245,7 +245,7 @@
                   <a:srgbClr val="DDEAF0"/>
                 </a:solidFill>
               </a:rPr>
-              <a:t>• Current UI is aligned to the supplied Apple Watch Ultra reference look.</a:t>
+              <a:t>• Current UI must align to this exact supplied Apple Watch Ultra reference.</a:t>
             </a:r>
             <a:endParaRPr lang="en-US" sz="1750"/>
           </a:p>
@@ -305,7 +305,7 @@
                   <a:srgbClr val="8EA7B3"/>
                 </a:solidFill>
               </a:rPr>
-              <a:t>Visual standard: black canvas, large mono-style metrics, thin functional borders, blue/green/yellow/red status colors.</a:t>
+              <a:t>Visual standard: Apple Watch Ultra frame, underwater bubbles background, black screen, large white metrics, blue/green/yellow/red functional colors.</a:t>
             </a:r>
             <a:endParaRPr lang="en-US" sz="1050"/>
           </a:p>
@@ -385,7 +385,7 @@
                   <a:srgbClr val="FFD60A"/>
                 </a:solidFill>
               </a:rPr>
-              <a:t>Apple Watch Ultra live UI direction</a:t>
+              <a:t>Reference look and feel</a:t>
             </a:r>
             <a:endParaRPr lang="en-US" sz="1300"/>
           </a:p>
@@ -632,7 +632,7 @@
                   <a:srgbClr val="8EA7B3"/>
                 </a:solidFill>
               </a:rPr>
-              <a:t>Visual standard: black canvas, large mono-style metrics, thin functional borders, blue/green/yellow/red status colors.</a:t>
+              <a:t>Visual standard: Apple Watch Ultra frame, underwater bubbles background, black screen, large white metrics, blue/green/yellow/red functional colors.</a:t>
             </a:r>
             <a:endParaRPr lang="en-US" sz="1050"/>
           </a:p>
@@ -712,7 +712,7 @@
                   <a:srgbClr val="FFD60A"/>
                 </a:solidFill>
               </a:rPr>
-              <a:t>Apple Watch Ultra live UI direction</a:t>
+              <a:t>Reference look and feel</a:t>
             </a:r>
             <a:endParaRPr lang="en-US" sz="1300"/>
           </a:p>
@@ -959,7 +959,7 @@
                   <a:srgbClr val="8EA7B3"/>
                 </a:solidFill>
               </a:rPr>
-              <a:t>Visual standard: black canvas, large mono-style metrics, thin functional borders, blue/green/yellow/red status colors.</a:t>
+              <a:t>Visual standard: Apple Watch Ultra frame, underwater bubbles background, black screen, large white metrics, blue/green/yellow/red functional colors.</a:t>
             </a:r>
             <a:endParaRPr lang="en-US" sz="1050"/>
           </a:p>
@@ -1039,7 +1039,7 @@
                   <a:srgbClr val="FFD60A"/>
                 </a:solidFill>
               </a:rPr>
-              <a:t>Apple Watch Ultra live UI direction</a:t>
+              <a:t>Reference look and feel</a:t>
             </a:r>
             <a:endParaRPr lang="en-US" sz="1300"/>
           </a:p>
@@ -1286,7 +1286,7 @@
                   <a:srgbClr val="8EA7B3"/>
                 </a:solidFill>
               </a:rPr>
-              <a:t>Visual standard: black canvas, large mono-style metrics, thin functional borders, blue/green/yellow/red status colors.</a:t>
+              <a:t>Visual standard: Apple Watch Ultra frame, underwater bubbles background, black screen, large white metrics, blue/green/yellow/red functional colors.</a:t>
             </a:r>
             <a:endParaRPr lang="en-US" sz="1050"/>
           </a:p>
@@ -1366,7 +1366,7 @@
                   <a:srgbClr val="FFD60A"/>
                 </a:solidFill>
               </a:rPr>
-              <a:t>Apple Watch Ultra live UI direction</a:t>
+              <a:t>Reference look and feel</a:t>
             </a:r>
             <a:endParaRPr lang="en-US" sz="1300"/>
           </a:p>
@@ -1613,7 +1613,7 @@
                   <a:srgbClr val="8EA7B3"/>
                 </a:solidFill>
               </a:rPr>
-              <a:t>Visual standard: black canvas, large mono-style metrics, thin functional borders, blue/green/yellow/red status colors.</a:t>
+              <a:t>Visual standard: Apple Watch Ultra frame, underwater bubbles background, black screen, large white metrics, blue/green/yellow/red functional colors.</a:t>
             </a:r>
             <a:endParaRPr lang="en-US" sz="1050"/>
           </a:p>
@@ -1693,7 +1693,7 @@
                   <a:srgbClr val="FFD60A"/>
                 </a:solidFill>
               </a:rPr>
-              <a:t>Apple Watch Ultra live UI direction</a:t>
+              <a:t>Reference look and feel</a:t>
             </a:r>
             <a:endParaRPr lang="en-US" sz="1300"/>
           </a:p>
@@ -1940,7 +1940,7 @@
                   <a:srgbClr val="8EA7B3"/>
                 </a:solidFill>
               </a:rPr>
-              <a:t>Visual standard: black canvas, large mono-style metrics, thin functional borders, blue/green/yellow/red status colors.</a:t>
+              <a:t>Visual standard: Apple Watch Ultra frame, underwater bubbles background, black screen, large white metrics, blue/green/yellow/red functional colors.</a:t>
             </a:r>
             <a:endParaRPr lang="en-US" sz="1050"/>
           </a:p>
@@ -2020,7 +2020,7 @@
                   <a:srgbClr val="FFD60A"/>
                 </a:solidFill>
               </a:rPr>
-              <a:t>Apple Watch Ultra live UI direction</a:t>
+              <a:t>Reference look and feel</a:t>
             </a:r>
             <a:endParaRPr lang="en-US" sz="1300"/>
           </a:p>
@@ -2267,7 +2267,7 @@
                   <a:srgbClr val="8EA7B3"/>
                 </a:solidFill>
               </a:rPr>
-              <a:t>Visual standard: black canvas, large mono-style metrics, thin functional borders, blue/green/yellow/red status colors.</a:t>
+              <a:t>Visual standard: Apple Watch Ultra frame, underwater bubbles background, black screen, large white metrics, blue/green/yellow/red functional colors.</a:t>
             </a:r>
             <a:endParaRPr lang="en-US" sz="1050"/>
           </a:p>
@@ -2347,7 +2347,7 @@
                   <a:srgbClr val="FFD60A"/>
                 </a:solidFill>
               </a:rPr>
-              <a:t>Apple Watch Ultra live UI direction</a:t>
+              <a:t>Reference look and feel</a:t>
             </a:r>
             <a:endParaRPr lang="en-US" sz="1300"/>
           </a:p>
@@ -2594,7 +2594,7 @@
                   <a:srgbClr val="8EA7B3"/>
                 </a:solidFill>
               </a:rPr>
-              <a:t>Visual standard: black canvas, large mono-style metrics, thin functional borders, blue/green/yellow/red status colors.</a:t>
+              <a:t>Visual standard: Apple Watch Ultra frame, underwater bubbles background, black screen, large white metrics, blue/green/yellow/red functional colors.</a:t>
             </a:r>
             <a:endParaRPr lang="en-US" sz="1050"/>
           </a:p>
@@ -2674,7 +2674,7 @@
                   <a:srgbClr val="FFD60A"/>
                 </a:solidFill>
               </a:rPr>
-              <a:t>Apple Watch Ultra live UI direction</a:t>
+              <a:t>Reference look and feel</a:t>
             </a:r>
             <a:endParaRPr lang="en-US" sz="1300"/>
           </a:p>
@@ -2921,7 +2921,7 @@
                   <a:srgbClr val="8EA7B3"/>
                 </a:solidFill>
               </a:rPr>
-              <a:t>Visual standard: black canvas, large mono-style metrics, thin functional borders, blue/green/yellow/red status colors.</a:t>
+              <a:t>Visual standard: Apple Watch Ultra frame, underwater bubbles background, black screen, large white metrics, blue/green/yellow/red functional colors.</a:t>
             </a:r>
             <a:endParaRPr lang="en-US" sz="1050"/>
           </a:p>
@@ -3001,7 +3001,7 @@
                   <a:srgbClr val="FFD60A"/>
                 </a:solidFill>
               </a:rPr>
-              <a:t>Apple Watch Ultra live UI direction</a:t>
+              <a:t>Reference look and feel</a:t>
             </a:r>
             <a:endParaRPr lang="en-US" sz="1300"/>
           </a:p>

</xml_diff>